<commit_message>
Carátula con datos de UNA-Puno y logos institucionales
Co-Authored-By: Claude Opus 5.5 <noreply@anthropic.com>
Claude-Session: https://claude.ai/code/session_01HCuiS5D5ZmuYnxoLkxQF8p
</commit_message>
<xml_diff>
--- a/Pavimento_Flexible_y_Bermas_Oscar_Mamani.pptx
+++ b/Pavimento_Flexible_y_Bermas_Oscar_Mamani.pptx
@@ -2621,16 +2621,64 @@
           <a:chExt cx="0" cy="0"/>
         </a:xfrm>
       </p:grpSpPr>
-      <p:sp>
-        <p:nvSpPr>
-          <p:cNvPr id="2" name="Text 0"/>
+      <p:pic>
+        <p:nvPicPr>
+          <p:cNvPr id="2" name="Image 0" descr="/home/user/work/build/logo_una.png">    </p:cNvPr>
+          <p:cNvPicPr>
+            <a:picLocks noChangeAspect="1"/>
+          </p:cNvPicPr>
+          <p:nvPr/>
+        </p:nvPicPr>
+        <p:blipFill>
+          <a:blip r:embed="rId1"/>
+          <a:stretch>
+            <a:fillRect/>
+          </a:stretch>
+        </p:blipFill>
+        <p:spPr>
+          <a:xfrm>
+            <a:off x="548640" y="365760"/>
+            <a:ext cx="795528" cy="868680"/>
+          </a:xfrm>
+          <a:prstGeom prst="rect">
+            <a:avLst/>
+          </a:prstGeom>
+        </p:spPr>
+      </p:pic>
+      <p:pic>
+        <p:nvPicPr>
+          <p:cNvPr id="3" name="Image 1" descr="/home/user/work/build/logo_ic.png">    </p:cNvPr>
+          <p:cNvPicPr>
+            <a:picLocks noChangeAspect="1"/>
+          </p:cNvPicPr>
+          <p:nvPr/>
+        </p:nvPicPr>
+        <p:blipFill>
+          <a:blip r:embed="rId2"/>
+          <a:stretch>
+            <a:fillRect/>
+          </a:stretch>
+        </p:blipFill>
+        <p:spPr>
+          <a:xfrm>
+            <a:off x="1508760" y="365760"/>
+            <a:ext cx="941832" cy="868680"/>
+          </a:xfrm>
+          <a:prstGeom prst="rect">
+            <a:avLst/>
+          </a:prstGeom>
+        </p:spPr>
+      </p:pic>
+      <p:sp>
+        <p:nvSpPr>
+          <p:cNvPr id="4" name="Text 0"/>
           <p:cNvSpPr txBox="1"/>
           <p:nvPr/>
         </p:nvSpPr>
         <p:spPr>
           <a:xfrm>
-            <a:off x="548640" y="502920"/>
-            <a:ext cx="6766560" cy="320040"/>
+            <a:off x="2651760" y="457200"/>
+            <a:ext cx="6858000" cy="320040"/>
           </a:xfrm>
           <a:prstGeom prst="rect">
             <a:avLst/>
@@ -2646,7 +2694,7 @@
               <a:buNone/>
             </a:pPr>
             <a:r>
-              <a:rPr lang="en-US" sz="1400" b="1" spc="200" kern="0" dirty="0">
+              <a:rPr lang="en-US" sz="1400" b="1" spc="100" kern="0" dirty="0">
                 <a:solidFill>
                   <a:srgbClr val="FFFFFF"/>
                 </a:solidFill>
@@ -2654,7 +2702,7 @@
                 <a:ea typeface="Calibri" pitchFamily="34" charset="-122"/>
                 <a:cs typeface="Calibri" pitchFamily="34" charset="-120"/>
               </a:rPr>
-              <a:t>[NOMBRE DE LA UNIVERSIDAD]</a:t>
+              <a:t>UNIVERSIDAD NACIONAL DEL ALTIPLANO – PUNO</a:t>
             </a:r>
             <a:endParaRPr lang="en-US" sz="1400" dirty="0"/>
           </a:p>
@@ -2662,14 +2710,14 @@
       </p:sp>
       <p:sp>
         <p:nvSpPr>
-          <p:cNvPr id="3" name="Text 1"/>
+          <p:cNvPr id="5" name="Text 1"/>
           <p:cNvSpPr txBox="1"/>
           <p:nvPr/>
         </p:nvSpPr>
         <p:spPr>
           <a:xfrm>
-            <a:off x="548640" y="822960"/>
-            <a:ext cx="6766560" cy="274320"/>
+            <a:off x="2651760" y="804672"/>
+            <a:ext cx="5029200" cy="274320"/>
           </a:xfrm>
           <a:prstGeom prst="rect">
             <a:avLst/>
@@ -2685,7 +2733,7 @@
               <a:buNone/>
             </a:pPr>
             <a:r>
-              <a:rPr lang="en-US" sz="1200" dirty="0">
+              <a:rPr lang="en-US" sz="1300" dirty="0">
                 <a:solidFill>
                   <a:srgbClr val="AEB4BC"/>
                 </a:solidFill>
@@ -2693,15 +2741,15 @@
                 <a:ea typeface="Calibri" pitchFamily="34" charset="-122"/>
                 <a:cs typeface="Calibri" pitchFamily="34" charset="-120"/>
               </a:rPr>
-              <a:t>[Facultad / Escuela Profesional de Ingeniería Civil]</a:t>
-            </a:r>
-            <a:endParaRPr lang="en-US" sz="1200" dirty="0"/>
+              <a:t>Maestría en Ingeniería Civil</a:t>
+            </a:r>
+            <a:endParaRPr lang="en-US" sz="1300" dirty="0"/>
           </a:p>
         </p:txBody>
       </p:sp>
       <p:sp>
         <p:nvSpPr>
-          <p:cNvPr id="4" name="Text 2"/>
+          <p:cNvPr id="6" name="Text 2"/>
           <p:cNvSpPr txBox="1"/>
           <p:nvPr/>
         </p:nvSpPr>
@@ -2740,7 +2788,7 @@
       </p:sp>
       <p:sp>
         <p:nvSpPr>
-          <p:cNvPr id="5" name="Text 3"/>
+          <p:cNvPr id="7" name="Text 3"/>
           <p:cNvSpPr txBox="1"/>
           <p:nvPr/>
         </p:nvSpPr>
@@ -2779,7 +2827,7 @@
       </p:sp>
       <p:sp>
         <p:nvSpPr>
-          <p:cNvPr id="6" name="Text 4"/>
+          <p:cNvPr id="8" name="Text 4"/>
           <p:cNvSpPr txBox="1"/>
           <p:nvPr/>
         </p:nvSpPr>
@@ -2818,7 +2866,7 @@
       </p:sp>
       <p:sp>
         <p:nvSpPr>
-          <p:cNvPr id="7" name="Text 5"/>
+          <p:cNvPr id="9" name="Text 5"/>
           <p:cNvSpPr txBox="1"/>
           <p:nvPr/>
         </p:nvSpPr>
@@ -2849,7 +2897,7 @@
                 <a:ea typeface="Calibri" pitchFamily="34" charset="-122"/>
                 <a:cs typeface="Calibri" pitchFamily="34" charset="-120"/>
               </a:rPr>
-              <a:t>PRESENTADO POR</a:t>
+              <a:t>MAESTRANTE</a:t>
             </a:r>
             <a:endParaRPr lang="en-US" sz="1100" dirty="0"/>
           </a:p>
@@ -2857,7 +2905,7 @@
       </p:sp>
       <p:sp>
         <p:nvSpPr>
-          <p:cNvPr id="8" name="Text 6"/>
+          <p:cNvPr id="10" name="Text 6"/>
           <p:cNvSpPr txBox="1"/>
           <p:nvPr/>
         </p:nvSpPr>
@@ -2896,7 +2944,7 @@
       </p:sp>
       <p:sp>
         <p:nvSpPr>
-          <p:cNvPr id="9" name="Text 7"/>
+          <p:cNvPr id="11" name="Text 7"/>
           <p:cNvSpPr txBox="1"/>
           <p:nvPr/>
         </p:nvSpPr>
@@ -2927,7 +2975,7 @@
                 <a:ea typeface="Calibri" pitchFamily="34" charset="-122"/>
                 <a:cs typeface="Calibri" pitchFamily="34" charset="-120"/>
               </a:rPr>
-              <a:t>CURSO</a:t>
+              <a:t>PROGRAMA</a:t>
             </a:r>
             <a:endParaRPr lang="en-US" sz="1100" dirty="0"/>
           </a:p>
@@ -2935,7 +2983,7 @@
       </p:sp>
       <p:sp>
         <p:nvSpPr>
-          <p:cNvPr id="10" name="Text 8"/>
+          <p:cNvPr id="12" name="Text 8"/>
           <p:cNvSpPr txBox="1"/>
           <p:nvPr/>
         </p:nvSpPr>
@@ -2966,7 +3014,7 @@
                 <a:ea typeface="Calibri" pitchFamily="34" charset="-122"/>
                 <a:cs typeface="Calibri" pitchFamily="34" charset="-120"/>
               </a:rPr>
-              <a:t>[Nombre del curso]</a:t>
+              <a:t>Maestría en Ingeniería Civil</a:t>
             </a:r>
             <a:endParaRPr lang="en-US" sz="1500" dirty="0"/>
           </a:p>
@@ -2974,7 +3022,7 @@
       </p:sp>
       <p:sp>
         <p:nvSpPr>
-          <p:cNvPr id="11" name="Text 9"/>
+          <p:cNvPr id="13" name="Text 9"/>
           <p:cNvSpPr txBox="1"/>
           <p:nvPr/>
         </p:nvSpPr>
@@ -3005,7 +3053,7 @@
                 <a:ea typeface="Calibri" pitchFamily="34" charset="-122"/>
                 <a:cs typeface="Calibri" pitchFamily="34" charset="-120"/>
               </a:rPr>
-              <a:t>DOCENTE</a:t>
+              <a:t>GRUPO</a:t>
             </a:r>
             <a:endParaRPr lang="en-US" sz="1100" dirty="0"/>
           </a:p>
@@ -3013,7 +3061,7 @@
       </p:sp>
       <p:sp>
         <p:nvSpPr>
-          <p:cNvPr id="12" name="Text 10"/>
+          <p:cNvPr id="14" name="Text 10"/>
           <p:cNvSpPr txBox="1"/>
           <p:nvPr/>
         </p:nvSpPr>
@@ -3044,7 +3092,7 @@
                 <a:ea typeface="Calibri" pitchFamily="34" charset="-122"/>
                 <a:cs typeface="Calibri" pitchFamily="34" charset="-120"/>
               </a:rPr>
-              <a:t>[Nombre del docente]</a:t>
+              <a:t>Único</a:t>
             </a:r>
             <a:endParaRPr lang="en-US" sz="1500" dirty="0"/>
           </a:p>
@@ -3052,7 +3100,7 @@
       </p:sp>
       <p:sp>
         <p:nvSpPr>
-          <p:cNvPr id="13" name="Text 11"/>
+          <p:cNvPr id="15" name="Text 11"/>
           <p:cNvSpPr txBox="1"/>
           <p:nvPr/>
         </p:nvSpPr>
@@ -3083,7 +3131,7 @@
                 <a:ea typeface="Calibri" pitchFamily="34" charset="-122"/>
                 <a:cs typeface="Calibri" pitchFamily="34" charset="-120"/>
               </a:rPr>
-              <a:t>FECHA</a:t>
+              <a:t>LUGAR</a:t>
             </a:r>
             <a:endParaRPr lang="en-US" sz="1100" dirty="0"/>
           </a:p>
@@ -3091,7 +3139,7 @@
       </p:sp>
       <p:sp>
         <p:nvSpPr>
-          <p:cNvPr id="14" name="Text 12"/>
+          <p:cNvPr id="16" name="Text 12"/>
           <p:cNvSpPr txBox="1"/>
           <p:nvPr/>
         </p:nvSpPr>
@@ -3122,7 +3170,7 @@
                 <a:ea typeface="Calibri" pitchFamily="34" charset="-122"/>
                 <a:cs typeface="Calibri" pitchFamily="34" charset="-120"/>
               </a:rPr>
-              <a:t>[Lugar, fecha]</a:t>
+              <a:t>Puno, Perú · 2026</a:t>
             </a:r>
             <a:endParaRPr lang="en-US" sz="1500" dirty="0"/>
           </a:p>
@@ -3130,7 +3178,7 @@
       </p:sp>
       <p:sp>
         <p:nvSpPr>
-          <p:cNvPr id="15" name="Shape 13"/>
+          <p:cNvPr id="17" name="Shape 13"/>
           <p:cNvSpPr/>
           <p:nvPr/>
         </p:nvSpPr>
@@ -3155,7 +3203,7 @@
       </p:sp>
       <p:sp>
         <p:nvSpPr>
-          <p:cNvPr id="16" name="Text 14"/>
+          <p:cNvPr id="18" name="Text 14"/>
           <p:cNvSpPr txBox="1"/>
           <p:nvPr/>
         </p:nvSpPr>
@@ -3194,7 +3242,7 @@
       </p:sp>
       <p:sp>
         <p:nvSpPr>
-          <p:cNvPr id="17" name="Shape 15"/>
+          <p:cNvPr id="19" name="Shape 15"/>
           <p:cNvSpPr/>
           <p:nvPr/>
         </p:nvSpPr>
@@ -3219,7 +3267,7 @@
       </p:sp>
       <p:sp>
         <p:nvSpPr>
-          <p:cNvPr id="18" name="Text 16"/>
+          <p:cNvPr id="20" name="Text 16"/>
           <p:cNvSpPr txBox="1"/>
           <p:nvPr/>
         </p:nvSpPr>
@@ -3258,7 +3306,7 @@
       </p:sp>
       <p:sp>
         <p:nvSpPr>
-          <p:cNvPr id="19" name="Shape 17"/>
+          <p:cNvPr id="21" name="Shape 17"/>
           <p:cNvSpPr/>
           <p:nvPr/>
         </p:nvSpPr>
@@ -3283,7 +3331,7 @@
       </p:sp>
       <p:sp>
         <p:nvSpPr>
-          <p:cNvPr id="20" name="Text 18"/>
+          <p:cNvPr id="22" name="Text 18"/>
           <p:cNvSpPr txBox="1"/>
           <p:nvPr/>
         </p:nvSpPr>
@@ -3322,7 +3370,7 @@
       </p:sp>
       <p:sp>
         <p:nvSpPr>
-          <p:cNvPr id="21" name="Shape 19"/>
+          <p:cNvPr id="23" name="Shape 19"/>
           <p:cNvSpPr/>
           <p:nvPr/>
         </p:nvSpPr>
@@ -3347,7 +3395,7 @@
       </p:sp>
       <p:sp>
         <p:nvSpPr>
-          <p:cNvPr id="22" name="Text 20"/>
+          <p:cNvPr id="24" name="Text 20"/>
           <p:cNvSpPr txBox="1"/>
           <p:nvPr/>
         </p:nvSpPr>
@@ -3386,7 +3434,7 @@
       </p:sp>
       <p:sp>
         <p:nvSpPr>
-          <p:cNvPr id="23" name="Shape 21"/>
+          <p:cNvPr id="25" name="Shape 21"/>
           <p:cNvSpPr/>
           <p:nvPr/>
         </p:nvSpPr>
@@ -3411,7 +3459,7 @@
       </p:sp>
       <p:sp>
         <p:nvSpPr>
-          <p:cNvPr id="24" name="Shape 22"/>
+          <p:cNvPr id="26" name="Shape 22"/>
           <p:cNvSpPr/>
           <p:nvPr/>
         </p:nvSpPr>
@@ -3436,7 +3484,7 @@
       </p:sp>
       <p:sp>
         <p:nvSpPr>
-          <p:cNvPr id="25" name="Shape 23"/>
+          <p:cNvPr id="27" name="Shape 23"/>
           <p:cNvSpPr/>
           <p:nvPr/>
         </p:nvSpPr>
@@ -3461,7 +3509,7 @@
       </p:sp>
       <p:sp>
         <p:nvSpPr>
-          <p:cNvPr id="26" name="Shape 24"/>
+          <p:cNvPr id="28" name="Shape 24"/>
           <p:cNvSpPr/>
           <p:nvPr/>
         </p:nvSpPr>
@@ -3486,7 +3534,7 @@
       </p:sp>
       <p:sp>
         <p:nvSpPr>
-          <p:cNvPr id="27" name="Text 25"/>
+          <p:cNvPr id="29" name="Text 25"/>
           <p:cNvSpPr txBox="1"/>
           <p:nvPr/>
         </p:nvSpPr>
@@ -4971,7 +5019,7 @@
                 <a:ea typeface="Calibri" pitchFamily="34" charset="-122"/>
                 <a:cs typeface="Calibri" pitchFamily="34" charset="-120"/>
               </a:rPr>
-              <a:t>Oscar Javier Mamani Ancco</a:t>
+              <a:t>Oscar Javier Mamani Ancco · Maestría en Ingeniería Civil · UNA-Puno · 2026</a:t>
             </a:r>
             <a:endParaRPr lang="en-US" sz="1600" dirty="0"/>
           </a:p>

</xml_diff>

<commit_message>
Agregar curso Tecnología Avanzada de Asfaltos en carátula
Co-Authored-By: Claude Opus 5.5 <noreply@anthropic.com>
Claude-Session: https://claude.ai/code/session_01HCuiS5D5ZmuYnxoLkxQF8p
</commit_message>
<xml_diff>
--- a/Pavimento_Flexible_y_Bermas_Oscar_Mamani.pptx
+++ b/Pavimento_Flexible_y_Bermas_Oscar_Mamani.pptx
@@ -2717,7 +2717,7 @@
         <p:spPr>
           <a:xfrm>
             <a:off x="2651760" y="804672"/>
-            <a:ext cx="5029200" cy="274320"/>
+            <a:ext cx="6858000" cy="274320"/>
           </a:xfrm>
           <a:prstGeom prst="rect">
             <a:avLst/>
@@ -2741,7 +2741,7 @@
                 <a:ea typeface="Calibri" pitchFamily="34" charset="-122"/>
                 <a:cs typeface="Calibri" pitchFamily="34" charset="-120"/>
               </a:rPr>
-              <a:t>Maestría en Ingeniería Civil</a:t>
+              <a:t>Maestría en Ingeniería Civil · Tecnología Avanzada de Asfaltos</a:t>
             </a:r>
             <a:endParaRPr lang="en-US" sz="1300" dirty="0"/>
           </a:p>
@@ -2975,7 +2975,7 @@
                 <a:ea typeface="Calibri" pitchFamily="34" charset="-122"/>
                 <a:cs typeface="Calibri" pitchFamily="34" charset="-120"/>
               </a:rPr>
-              <a:t>PROGRAMA</a:t>
+              <a:t>CURSO</a:t>
             </a:r>
             <a:endParaRPr lang="en-US" sz="1100" dirty="0"/>
           </a:p>
@@ -3014,7 +3014,7 @@
                 <a:ea typeface="Calibri" pitchFamily="34" charset="-122"/>
                 <a:cs typeface="Calibri" pitchFamily="34" charset="-120"/>
               </a:rPr>
-              <a:t>Maestría en Ingeniería Civil</a:t>
+              <a:t>Tecnología Avanzada de Asfaltos</a:t>
             </a:r>
             <a:endParaRPr lang="en-US" sz="1500" dirty="0"/>
           </a:p>
@@ -5019,7 +5019,7 @@
                 <a:ea typeface="Calibri" pitchFamily="34" charset="-122"/>
                 <a:cs typeface="Calibri" pitchFamily="34" charset="-120"/>
               </a:rPr>
-              <a:t>Oscar Javier Mamani Ancco · Maestría en Ingeniería Civil · UNA-Puno · 2026</a:t>
+              <a:t>Oscar Javier Mamani Ancco · Tecnología Avanzada de Asfaltos · UNA-Puno · 2026</a:t>
             </a:r>
             <a:endParaRPr lang="en-US" sz="1600" dirty="0"/>
           </a:p>

</xml_diff>

<commit_message>
Agregar docente en carátula
Co-Authored-By: Claude Opus 5.5 <noreply@anthropic.com>
Claude-Session: https://claude.ai/code/session_01HCuiS5D5ZmuYnxoLkxQF8p
</commit_message>
<xml_diff>
--- a/Pavimento_Flexible_y_Bermas_Oscar_Mamani.pptx
+++ b/Pavimento_Flexible_y_Bermas_Oscar_Mamani.pptx
@@ -2872,7 +2872,7 @@
         </p:nvSpPr>
         <p:spPr>
           <a:xfrm>
-            <a:off x="548640" y="4572000"/>
+            <a:off x="548640" y="4434840"/>
             <a:ext cx="1737360" cy="329184"/>
           </a:xfrm>
           <a:prstGeom prst="rect">
@@ -2911,7 +2911,7 @@
         </p:nvSpPr>
         <p:spPr>
           <a:xfrm>
-            <a:off x="2286000" y="4572000"/>
+            <a:off x="2286000" y="4434840"/>
             <a:ext cx="4846320" cy="329184"/>
           </a:xfrm>
           <a:prstGeom prst="rect">
@@ -2950,7 +2950,7 @@
         </p:nvSpPr>
         <p:spPr>
           <a:xfrm>
-            <a:off x="548640" y="4974336"/>
+            <a:off x="548640" y="4800600"/>
             <a:ext cx="1737360" cy="329184"/>
           </a:xfrm>
           <a:prstGeom prst="rect">
@@ -2989,7 +2989,7 @@
         </p:nvSpPr>
         <p:spPr>
           <a:xfrm>
-            <a:off x="2286000" y="4974336"/>
+            <a:off x="2286000" y="4800600"/>
             <a:ext cx="4846320" cy="329184"/>
           </a:xfrm>
           <a:prstGeom prst="rect">
@@ -3028,7 +3028,7 @@
         </p:nvSpPr>
         <p:spPr>
           <a:xfrm>
-            <a:off x="548640" y="5376672"/>
+            <a:off x="548640" y="5166360"/>
             <a:ext cx="1737360" cy="329184"/>
           </a:xfrm>
           <a:prstGeom prst="rect">
@@ -3053,7 +3053,7 @@
                 <a:ea typeface="Calibri" pitchFamily="34" charset="-122"/>
                 <a:cs typeface="Calibri" pitchFamily="34" charset="-120"/>
               </a:rPr>
-              <a:t>GRUPO</a:t>
+              <a:t>DOCENTE</a:t>
             </a:r>
             <a:endParaRPr lang="en-US" sz="1100" dirty="0"/>
           </a:p>
@@ -3067,7 +3067,7 @@
         </p:nvSpPr>
         <p:spPr>
           <a:xfrm>
-            <a:off x="2286000" y="5376672"/>
+            <a:off x="2286000" y="5166360"/>
             <a:ext cx="4846320" cy="329184"/>
           </a:xfrm>
           <a:prstGeom prst="rect">
@@ -3092,7 +3092,7 @@
                 <a:ea typeface="Calibri" pitchFamily="34" charset="-122"/>
                 <a:cs typeface="Calibri" pitchFamily="34" charset="-120"/>
               </a:rPr>
-              <a:t>Único</a:t>
+              <a:t>Dr. César Edwin Guerra Ramos</a:t>
             </a:r>
             <a:endParaRPr lang="en-US" sz="1500" dirty="0"/>
           </a:p>
@@ -3106,7 +3106,7 @@
         </p:nvSpPr>
         <p:spPr>
           <a:xfrm>
-            <a:off x="548640" y="5779008"/>
+            <a:off x="548640" y="5532120"/>
             <a:ext cx="1737360" cy="329184"/>
           </a:xfrm>
           <a:prstGeom prst="rect">
@@ -3131,7 +3131,7 @@
                 <a:ea typeface="Calibri" pitchFamily="34" charset="-122"/>
                 <a:cs typeface="Calibri" pitchFamily="34" charset="-120"/>
               </a:rPr>
-              <a:t>LUGAR</a:t>
+              <a:t>GRUPO</a:t>
             </a:r>
             <a:endParaRPr lang="en-US" sz="1100" dirty="0"/>
           </a:p>
@@ -3145,7 +3145,7 @@
         </p:nvSpPr>
         <p:spPr>
           <a:xfrm>
-            <a:off x="2286000" y="5779008"/>
+            <a:off x="2286000" y="5532120"/>
             <a:ext cx="4846320" cy="329184"/>
           </a:xfrm>
           <a:prstGeom prst="rect">
@@ -3170,6 +3170,84 @@
                 <a:ea typeface="Calibri" pitchFamily="34" charset="-122"/>
                 <a:cs typeface="Calibri" pitchFamily="34" charset="-120"/>
               </a:rPr>
+              <a:t>Único</a:t>
+            </a:r>
+            <a:endParaRPr lang="en-US" sz="1500" dirty="0"/>
+          </a:p>
+        </p:txBody>
+      </p:sp>
+      <p:sp>
+        <p:nvSpPr>
+          <p:cNvPr id="17" name="Text 13"/>
+          <p:cNvSpPr txBox="1"/>
+          <p:nvPr/>
+        </p:nvSpPr>
+        <p:spPr>
+          <a:xfrm>
+            <a:off x="548640" y="5897880"/>
+            <a:ext cx="1737360" cy="329184"/>
+          </a:xfrm>
+          <a:prstGeom prst="rect">
+            <a:avLst/>
+          </a:prstGeom>
+          <a:noFill/>
+          <a:ln/>
+        </p:spPr>
+        <p:txBody>
+          <a:bodyPr wrap="square" lIns="0" tIns="0" rIns="0" bIns="0" rtlCol="0" anchor="ctr"/>
+          <a:lstStyle/>
+          <a:p>
+            <a:pPr indent="0" marL="0">
+              <a:buNone/>
+            </a:pPr>
+            <a:r>
+              <a:rPr lang="en-US" sz="1100" b="1" spc="100" kern="0" dirty="0">
+                <a:solidFill>
+                  <a:srgbClr val="F2B705"/>
+                </a:solidFill>
+                <a:latin typeface="Calibri" pitchFamily="34" charset="0"/>
+                <a:ea typeface="Calibri" pitchFamily="34" charset="-122"/>
+                <a:cs typeface="Calibri" pitchFamily="34" charset="-120"/>
+              </a:rPr>
+              <a:t>LUGAR</a:t>
+            </a:r>
+            <a:endParaRPr lang="en-US" sz="1100" dirty="0"/>
+          </a:p>
+        </p:txBody>
+      </p:sp>
+      <p:sp>
+        <p:nvSpPr>
+          <p:cNvPr id="18" name="Text 14"/>
+          <p:cNvSpPr txBox="1"/>
+          <p:nvPr/>
+        </p:nvSpPr>
+        <p:spPr>
+          <a:xfrm>
+            <a:off x="2286000" y="5897880"/>
+            <a:ext cx="4846320" cy="329184"/>
+          </a:xfrm>
+          <a:prstGeom prst="rect">
+            <a:avLst/>
+          </a:prstGeom>
+          <a:noFill/>
+          <a:ln/>
+        </p:spPr>
+        <p:txBody>
+          <a:bodyPr wrap="square" lIns="0" tIns="0" rIns="0" bIns="0" rtlCol="0" anchor="ctr"/>
+          <a:lstStyle/>
+          <a:p>
+            <a:pPr indent="0" marL="0">
+              <a:buNone/>
+            </a:pPr>
+            <a:r>
+              <a:rPr lang="en-US" sz="1500" dirty="0">
+                <a:solidFill>
+                  <a:srgbClr val="FFFFFF"/>
+                </a:solidFill>
+                <a:latin typeface="Calibri" pitchFamily="34" charset="0"/>
+                <a:ea typeface="Calibri" pitchFamily="34" charset="-122"/>
+                <a:cs typeface="Calibri" pitchFamily="34" charset="-120"/>
+              </a:rPr>
               <a:t>Puno, Perú · 2026</a:t>
             </a:r>
             <a:endParaRPr lang="en-US" sz="1500" dirty="0"/>
@@ -3178,7 +3256,7 @@
       </p:sp>
       <p:sp>
         <p:nvSpPr>
-          <p:cNvPr id="17" name="Shape 13"/>
+          <p:cNvPr id="19" name="Shape 15"/>
           <p:cNvSpPr/>
           <p:nvPr/>
         </p:nvSpPr>
@@ -3203,7 +3281,7 @@
       </p:sp>
       <p:sp>
         <p:nvSpPr>
-          <p:cNvPr id="18" name="Text 14"/>
+          <p:cNvPr id="20" name="Text 16"/>
           <p:cNvSpPr txBox="1"/>
           <p:nvPr/>
         </p:nvSpPr>
@@ -3242,7 +3320,7 @@
       </p:sp>
       <p:sp>
         <p:nvSpPr>
-          <p:cNvPr id="19" name="Shape 15"/>
+          <p:cNvPr id="21" name="Shape 17"/>
           <p:cNvSpPr/>
           <p:nvPr/>
         </p:nvSpPr>
@@ -3267,7 +3345,7 @@
       </p:sp>
       <p:sp>
         <p:nvSpPr>
-          <p:cNvPr id="20" name="Text 16"/>
+          <p:cNvPr id="22" name="Text 18"/>
           <p:cNvSpPr txBox="1"/>
           <p:nvPr/>
         </p:nvSpPr>
@@ -3306,7 +3384,7 @@
       </p:sp>
       <p:sp>
         <p:nvSpPr>
-          <p:cNvPr id="21" name="Shape 17"/>
+          <p:cNvPr id="23" name="Shape 19"/>
           <p:cNvSpPr/>
           <p:nvPr/>
         </p:nvSpPr>
@@ -3331,7 +3409,7 @@
       </p:sp>
       <p:sp>
         <p:nvSpPr>
-          <p:cNvPr id="22" name="Text 18"/>
+          <p:cNvPr id="24" name="Text 20"/>
           <p:cNvSpPr txBox="1"/>
           <p:nvPr/>
         </p:nvSpPr>
@@ -3370,7 +3448,7 @@
       </p:sp>
       <p:sp>
         <p:nvSpPr>
-          <p:cNvPr id="23" name="Shape 19"/>
+          <p:cNvPr id="25" name="Shape 21"/>
           <p:cNvSpPr/>
           <p:nvPr/>
         </p:nvSpPr>
@@ -3395,7 +3473,7 @@
       </p:sp>
       <p:sp>
         <p:nvSpPr>
-          <p:cNvPr id="24" name="Text 20"/>
+          <p:cNvPr id="26" name="Text 22"/>
           <p:cNvSpPr txBox="1"/>
           <p:nvPr/>
         </p:nvSpPr>
@@ -3434,7 +3512,7 @@
       </p:sp>
       <p:sp>
         <p:nvSpPr>
-          <p:cNvPr id="25" name="Shape 21"/>
+          <p:cNvPr id="27" name="Shape 23"/>
           <p:cNvSpPr/>
           <p:nvPr/>
         </p:nvSpPr>
@@ -3459,7 +3537,7 @@
       </p:sp>
       <p:sp>
         <p:nvSpPr>
-          <p:cNvPr id="26" name="Shape 22"/>
+          <p:cNvPr id="28" name="Shape 24"/>
           <p:cNvSpPr/>
           <p:nvPr/>
         </p:nvSpPr>
@@ -3484,7 +3562,7 @@
       </p:sp>
       <p:sp>
         <p:nvSpPr>
-          <p:cNvPr id="27" name="Shape 23"/>
+          <p:cNvPr id="29" name="Shape 25"/>
           <p:cNvSpPr/>
           <p:nvPr/>
         </p:nvSpPr>
@@ -3509,7 +3587,7 @@
       </p:sp>
       <p:sp>
         <p:nvSpPr>
-          <p:cNvPr id="28" name="Shape 24"/>
+          <p:cNvPr id="30" name="Shape 26"/>
           <p:cNvSpPr/>
           <p:nvPr/>
         </p:nvSpPr>
@@ -3534,7 +3612,7 @@
       </p:sp>
       <p:sp>
         <p:nvSpPr>
-          <p:cNvPr id="29" name="Text 25"/>
+          <p:cNvPr id="31" name="Text 27"/>
           <p:cNvSpPr txBox="1"/>
           <p:nvPr/>
         </p:nvSpPr>

</xml_diff>